<commit_message>
feat(parte-9): responder a incidentes de hardware
</commit_message>
<xml_diff>
--- a/classes/parte-9-forense-digital-y-respuesta-a-incidentes/215-playbooks-de-respuesta-a-incidentes/clase-215-presentacion.pptx
+++ b/classes/parte-9-forense-digital-y-respuesta-a-incidentes/215-playbooks-de-respuesta-a-incidentes/clase-215-presentacion.pptx
@@ -22,6 +22,7 @@
     <p:sldId id="270" r:id="rId21"/>
     <p:sldId id="271" r:id="rId22"/>
     <p:sldId id="272" r:id="rId23"/>
+    <p:sldId id="273" r:id="rId24"/>
   </p:sldIdLst>
   <p:sldSz cx="9144000" cy="6858000" type="screen4x3"/>
   <p:notesSz cx="6858000" cy="9144000"/>
@@ -3632,6 +3633,21 @@
               <a:t>•  Crea un diagrama de flujo del playbook de phishing.</a:t>
             </a:r>
           </a:p>
+          <a:p>
+            <a:pPr>
+              <a:spcAft>
+                <a:spcPts val="600"/>
+              </a:spcAft>
+            </a:pPr>
+            <a:r>
+              <a:rPr sz="1500">
+                <a:solidFill>
+                  <a:srgbClr val="22282E"/>
+                </a:solidFill>
+              </a:rPr>
+              <a:t>•  Adapta la plantilla a un adaptador USB-Ethernet desconocido: incluye seguridad física, estado volátil, custodia, aislamiento, análisis en banco y recuperación.</a:t>
+            </a:r>
+          </a:p>
         </p:txBody>
       </p:sp>
     </p:spTree>
@@ -4213,6 +4229,21 @@
               <a:t>•  Roberts y Brown — Intelligence-Driven Incident Response, O’Reilly, 2017: enfoque de respuesta guiada por inteligencia; complementar con normas y arquitectura actuales.</a:t>
             </a:r>
           </a:p>
+          <a:p>
+            <a:pPr>
+              <a:spcAft>
+                <a:spcPts val="600"/>
+              </a:spcAft>
+            </a:pPr>
+            <a:r>
+              <a:rPr sz="1500">
+                <a:solidFill>
+                  <a:srgbClr val="22282E"/>
+                </a:solidFill>
+              </a:rPr>
+              <a:t>•  NIST SP 800-53 Rev. 5, familias PE e IR: &lt;https://doi.org/10.6028/NIST.SP.800-53r5&gt; — integra protección física, monitoreo y respuesta; los controles se adaptan al riesgo del sistema.</a:t>
+            </a:r>
+          </a:p>
         </p:txBody>
       </p:sp>
     </p:spTree>
@@ -4224,6 +4255,125 @@
 </file>
 
 <file path=ppt/slides/slide17.xml><?xml version="1.0" encoding="utf-8"?>
+<p:sld xmlns:a="http://schemas.openxmlformats.org/drawingml/2006/main" xmlns:p="http://schemas.openxmlformats.org/presentationml/2006/main" xmlns:r="http://schemas.openxmlformats.org/officeDocument/2006/relationships">
+  <p:cSld>
+    <p:spTree>
+      <p:nvGrpSpPr>
+        <p:cNvPr id="1" name=""/>
+        <p:cNvGrpSpPr/>
+        <p:nvPr/>
+      </p:nvGrpSpPr>
+      <p:grpSpPr/>
+      <p:sp>
+        <p:nvSpPr>
+          <p:cNvPr id="2" name="TextBox 1"/>
+          <p:cNvSpPr txBox="1"/>
+          <p:nvPr/>
+        </p:nvSpPr>
+        <p:spPr>
+          <a:xfrm>
+            <a:off x="457200" y="320040"/>
+            <a:ext cx="8229600" cy="822960"/>
+          </a:xfrm>
+          <a:prstGeom prst="rect">
+            <a:avLst/>
+          </a:prstGeom>
+          <a:noFill/>
+        </p:spPr>
+        <p:txBody>
+          <a:bodyPr wrap="square">
+            <a:spAutoFit/>
+          </a:bodyPr>
+          <a:lstStyle/>
+          <a:p>
+            <a:r>
+              <a:rPr sz="2600" b="1">
+                <a:solidFill>
+                  <a:srgbClr val="0B3D2E"/>
+                </a:solidFill>
+              </a:rPr>
+              <a:t>🔬 Aplicación transversal</a:t>
+            </a:r>
+          </a:p>
+        </p:txBody>
+      </p:sp>
+      <p:sp>
+        <p:nvSpPr>
+          <p:cNvPr id="3" name="TextBox 2"/>
+          <p:cNvSpPr txBox="1"/>
+          <p:nvPr/>
+        </p:nvSpPr>
+        <p:spPr>
+          <a:xfrm>
+            <a:off x="457200" y="1280160"/>
+            <a:ext cx="8229600" cy="4937760"/>
+          </a:xfrm>
+          <a:prstGeom prst="rect">
+            <a:avLst/>
+          </a:prstGeom>
+          <a:noFill/>
+        </p:spPr>
+        <p:txBody>
+          <a:bodyPr wrap="square">
+            <a:spAutoFit/>
+          </a:bodyPr>
+          <a:lstStyle/>
+          <a:p>
+            <a:pPr>
+              <a:spcAft>
+                <a:spcPts val="600"/>
+              </a:spcAft>
+            </a:pPr>
+            <a:r>
+              <a:rPr sz="1500">
+                <a:solidFill>
+                  <a:srgbClr val="22282E"/>
+                </a:solidFill>
+              </a:rPr>
+              <a:t>•  Extiende la anatomía de esta clase con los ocho playbooks de custodia:</a:t>
+            </a:r>
+          </a:p>
+          <a:p>
+            <a:pPr>
+              <a:spcAft>
+                <a:spcPts val="600"/>
+              </a:spcAft>
+            </a:pPr>
+            <a:r>
+              <a:rPr sz="1500">
+                <a:solidFill>
+                  <a:srgbClr val="22282E"/>
+                </a:solidFill>
+              </a:rPr>
+              <a:t>•  pérdida de fondos, wallet, insider, exchange, API key, discrepancia, retiro no</a:t>
+            </a:r>
+          </a:p>
+          <a:p>
+            <a:pPr>
+              <a:spcAft>
+                <a:spcPts val="600"/>
+              </a:spcAft>
+            </a:pPr>
+            <a:r>
+              <a:rPr sz="1500">
+                <a:solidFill>
+                  <a:srgbClr val="22282E"/>
+                </a:solidFill>
+              </a:rPr>
+              <a:t>•  autorizado y ledger. Compara sus decisiones de preservación y contención.</a:t>
+            </a:r>
+          </a:p>
+        </p:txBody>
+      </p:sp>
+    </p:spTree>
+  </p:cSld>
+  <p:clrMapOvr>
+    <a:masterClrMapping/>
+  </p:clrMapOvr>
+</p:sld>
+</file>
+
+<file path=ppt/slides/slide18.xml><?xml version="1.0" encoding="utf-8"?>
 <p:sld xmlns:a="http://schemas.openxmlformats.org/drawingml/2006/main" xmlns:p="http://schemas.openxmlformats.org/presentationml/2006/main" xmlns:r="http://schemas.openxmlformats.org/officeDocument/2006/relationships">
   <p:cSld>
     <p:spTree>
@@ -4896,7 +5046,7 @@
                   <a:srgbClr val="22282E"/>
                 </a:solidFill>
               </a:rPr>
-              <a:t>•  Cada playbook tiene propietario, versión, cambios, dependencias y fecha de la última prueba. Un tabletop prueba autoridad y coordinación; una prueba técnica valida comandos y permisos. Los hallazgos…</a:t>
+              <a:t>•  Un dispositivo físico o radio sospechosa cambia de nuevo las preguntas. Ante un cable, adaptador USB, puente de red, lector RFID o AP desconocido, se documentan ubicación, conexiones, alimentación…</a:t>
             </a:r>
           </a:p>
         </p:txBody>

</xml_diff>